<commit_message>
Prensaestopa v2: correcciones del verificador, mapa y presentación actualizados
Co-Authored-By: Claude Sonnet 5.5 <noreply@anthropic.com>
Claude-Session: https://claude.ai/code/session_01HuaXZZFETmms2hCVjsvSSn
</commit_message>
<xml_diff>
--- a/docs/entregables/presentacion_bomba_prensaestopa.pptx
+++ b/docs/entregables/presentacion_bomba_prensaestopa.pptx
@@ -126,20 +126,20 @@
   <p:extLst>
     <p:ext uri="{521415D9-36F7-43E2-AB2F-B90AF26B5E84}">
       <p14:sectionLst xmlns:p14="http://schemas.microsoft.com/office/powerpoint/2010/main">
-        <p14:section name="Inicio" id="{af6eb44a-09c0-7f1a-aed4-8ec7c3c21413}">
+        <p14:section name="Inicio" id="{aaa74e2d-b4aa-34ee-4312-d7b341e84286}">
           <p14:sldIdLst>
             <p14:sldId id="256"/>
             <p14:sldId id="257"/>
           </p14:sldIdLst>
         </p14:section>
-        <p14:section name="Alcance y método" id="{4234e256-3155-c6b6-2e21-9cae271fa731}">
+        <p14:section name="Alcance y método" id="{916170fe-8e4c-608e-12b6-42c14e014a30}">
           <p14:sldIdLst>
             <p14:sldId id="258"/>
             <p14:sldId id="259"/>
             <p14:sldId id="260"/>
           </p14:sldIdLst>
         </p14:section>
-        <p14:section name="Análisis de causa raíz" id="{a268099e-602f-fd77-68e6-d66485809d94}">
+        <p14:section name="Análisis de causa raíz" id="{a686ccd8-8826-066f-871f-3ea997ae6659}">
           <p14:sldIdLst>
             <p14:sldId id="261"/>
             <p14:sldId id="262"/>
@@ -148,7 +148,7 @@
             <p14:sldId id="265"/>
           </p14:sldIdLst>
         </p14:section>
-        <p14:section name="Monitoreo, datos y normas" id="{6f4c6738-4a34-4277-ef16-d602057e1cf8}">
+        <p14:section name="Monitoreo, datos y normas" id="{bfaf31da-5a3e-8168-969b-ba96868953b8}">
           <p14:sldIdLst>
             <p14:sldId id="266"/>
             <p14:sldId id="267"/>
@@ -6297,7 +6297,7 @@
                   <a:schemeClr val="tx1"/>
                 </a:solidFill>
               </a:rPr>
-              <a:t>Cada paquete es una unidad con fecha de inicio, fecha de falla o de censura. Empezar por descriptivo: Kaplan-Meier (kaplan_meier y km_failure_quantile con su banda) y Weibull con fit_weibull_mle, con intervalo de la forma y advertencias del kit; la censura se trata como tal, nunca como RUL = 0.…</a:t>
+              <a:t>Cada paquete es una unidad con fecha de inicio, fecha de falla o de censura. Comparar dos grupos con logrank_test (por ejemplo ajuste programado frente a ajuste solo por fuga, o goteo en una clase frente a otra) usando un análisis de punto fijo: el grupo se asigna por el estado en una fecha de…</a:t>
             </a:r>
             <a:endParaRPr lang="en-US" sz="1200" dirty="0"/>
           </a:p>
@@ -14255,6 +14255,23 @@
                   <a:schemeClr val="tx1"/>
                 </a:solidFill>
               </a:rPr>
+              <a:t>Distribuidor de empaquetaduras (blog comercial) (s. f.). Cómo evitar el fallo prematuro de la empaquetadura en bombas. Blog de un distribuidor industrial; fragmento pegado por la persona; página no abierta desde el entorno.</a:t>
+            </a:r>
+            <a:endParaRPr lang="en-US" sz="1100" dirty="0"/>
+          </a:p>
+          <a:p>
+            <a:pPr indent="0" marL="0">
+              <a:spcAft>
+                <a:spcPts val="800"/>
+              </a:spcAft>
+              <a:buNone/>
+            </a:pPr>
+            <a:r>
+              <a:rPr lang="en-US" sz="1100" dirty="0">
+                <a:solidFill>
+                  <a:schemeClr val="tx1"/>
+                </a:solidFill>
+              </a:rPr>
               <a:t>Lillelund, C. M., Pannullo, F., Jakobsen, M. O., Morante, M., &amp; Pedersen, C. F. (2025). RULSurv: A probabilistic survival-based method for early censoring-aware prediction of remaining useful life in ball bearings. arXiv 2405.01614 (cabecera del preprint: Expert Systems with Applications). https://arxiv.org/abs/2405.01614</a:t>
             </a:r>
             <a:endParaRPr lang="en-US" sz="1100" dirty="0"/>
@@ -22797,7 +22814,7 @@
       </p:sp>
       <p:sp>
         <p:nvSpPr>
-          <p:cNvPr id="10" name="tarjeta Material  |  2 con respaldo, 3 síntesis"/>
+          <p:cNvPr id="10" name="tarjeta Material  |  2 con respaldo, 4 síntesis"/>
           <p:cNvSpPr/>
           <p:nvPr/>
         </p:nvSpPr>
@@ -22852,7 +22869,7 @@
                   <a:schemeClr val="tx1"/>
                 </a:solidFill>
               </a:rPr>
-              <a:t>Material  |  2 con respaldo, 3 síntesis</a:t>
+              <a:t>Material  |  2 con respaldo, 4 síntesis</a:t>
             </a:r>
             <a:endParaRPr lang="en-US" sz="1300" dirty="0"/>
           </a:p>
@@ -22892,7 +22909,25 @@
                   <a:schemeClr val="tx1"/>
                 </a:solidFill>
               </a:rPr>
-              <a:t>Lubricante degradado, inadecuado o incompatible, o contaminado con agua.</a:t>
+              <a:t>Lubricante degradado o inadecuado (falla de lubricante).</a:t>
+            </a:r>
+            <a:endParaRPr lang="en-US" sz="1100" dirty="0"/>
+          </a:p>
+          <a:p>
+            <a:pPr marL="342900" indent="-342900">
+              <a:spcAft>
+                <a:spcPts val="400"/>
+              </a:spcAft>
+              <a:buSzPct val="100000"/>
+              <a:buChar char="•"/>
+            </a:pPr>
+            <a:r>
+              <a:rPr lang="en-US" sz="1100" dirty="0">
+                <a:solidFill>
+                  <a:schemeClr val="tx1"/>
+                </a:solidFill>
+              </a:rPr>
+              <a:t>Lubricante contaminado con agua del prensaestopa (hipótesis).</a:t>
             </a:r>
             <a:endParaRPr lang="en-US" sz="1100" dirty="0"/>
           </a:p>
@@ -22911,24 +22946,6 @@
                 </a:solidFill>
               </a:rPr>
               <a:t>Corrosión y desgaste de las superficies del rodamiento.</a:t>
-            </a:r>
-            <a:endParaRPr lang="en-US" sz="1100" dirty="0"/>
-          </a:p>
-          <a:p>
-            <a:pPr marL="342900" indent="-342900">
-              <a:spcAft>
-                <a:spcPts val="400"/>
-              </a:spcAft>
-              <a:buSzPct val="100000"/>
-              <a:buChar char="•"/>
-            </a:pPr>
-            <a:r>
-              <a:rPr lang="en-US" sz="1100" dirty="0">
-                <a:solidFill>
-                  <a:schemeClr val="tx1"/>
-                </a:solidFill>
-              </a:rPr>
-              <a:t>Fatiga normal del material (descascarado): fin de vida esperado y no falla prematura.</a:t>
             </a:r>
             <a:endParaRPr lang="en-US" sz="1100" dirty="0"/>
           </a:p>
@@ -25679,7 +25696,7 @@
                           <a:ea typeface="Calibri" pitchFamily="34" charset="-122"/>
                           <a:cs typeface="Calibri" pitchFamily="34" charset="-120"/>
                         </a:rPr>
-                        <a:t>Empaquetadura con ajuste insuficiente (fuga excesiva)</a:t>
+                        <a:t>Empaquetadura con ajuste insuficiente (fuga)</a:t>
                       </a:r>
                       <a:endParaRPr lang="en-US" sz="1100" dirty="0">
                         <a:latin typeface="Calibri" charset="0"/>
@@ -26595,7 +26612,7 @@
                           <a:ea typeface="Calibri" pitchFamily="34" charset="-122"/>
                           <a:cs typeface="Calibri" pitchFamily="34" charset="-120"/>
                         </a:rPr>
-                        <a:t>En condición (análisis de lubricante) y, si el agua se confirma, protección (FM14) (consecuencia: A confirmar). El análisis de lubricante…</a:t>
+                        <a:t>En condición (análisis de lubricante) y, si el agua se confirma, protección (el modo de protección del soporte (sin fuente; ver vacíos))…</a:t>
                       </a:r>
                       <a:endParaRPr lang="en-US" sz="1000" dirty="0">
                         <a:latin typeface="Calibri" charset="0"/>
@@ -26924,7 +26941,7 @@
                           <a:ea typeface="Calibri" pitchFamily="34" charset="-122"/>
                           <a:cs typeface="Calibri" pitchFamily="34" charset="-120"/>
                         </a:rPr>
-                        <a:t>FM13</a:t>
+                        <a:t>el modo de desgaste de camisa (sin fuente; ver vacíos)</a:t>
                       </a:r>
                       <a:endParaRPr lang="en-US" sz="1100" dirty="0">
                         <a:latin typeface="Calibri" charset="0"/>
@@ -27186,7 +27203,7 @@
                           <a:ea typeface="Calibri" pitchFamily="34" charset="-122"/>
                           <a:cs typeface="Calibri" pitchFamily="34" charset="-120"/>
                         </a:rPr>
-                        <a:t>FM14</a:t>
+                        <a:t>el modo de protección del soporte (sin fuente; ver vacíos)</a:t>
                       </a:r>
                       <a:endParaRPr lang="en-US" sz="1100" dirty="0">
                         <a:latin typeface="Calibri" charset="0"/>

</xml_diff>